<commit_message>
Trim HR deck to 5 slides; noun-form titles
Per feedback: fewer slides and slide titles ending as noun phrases (명사형).
Cut to 5 (title · 핵심 · 3-step diagram · 작업본vs최종본 comparison ·
closing), dropping the metrics and effects/limits slides. All titles now
end in noun form:
  개인정보 보호 게이트웨이 · 식별자는 토큰화, 숫자는 원본 유지 ·
  세 단계 처리 · 작업본은 토큰, 최종본은 실명 · 도입 안내
Shortened the closing subtitle so it no longer wraps mid-word.

report template (black header / white body) kept; validated; all 5
slides re-rendered and visually QA'd via Keynote.

Co-Authored-By: Claude Opus 4.8 (1M context) <noreply@anthropic.com>
</commit_message>
<xml_diff>
--- a/claudedocs/pii-gateway-hr-deck.pptx
+++ b/claudedocs/pii-gateway-hr-deck.pptx
@@ -10,8 +10,6 @@
     <p:sldId id="258" r:id="rId9"/>
     <p:sldId id="259" r:id="rId10"/>
     <p:sldId id="260" r:id="rId11"/>
-    <p:sldId id="261" r:id="rId12"/>
-    <p:sldId id="262" r:id="rId13"/>
   </p:sldIdLst>
   <p:sldSz cx="12191695" cy="6858000" type="screen4x3"/>
   <p:notesSz cx="6858000" cy="9144000"/>
@@ -3250,7 +3248,7 @@
                 </a:solidFill>
                 <a:latin typeface="Calibri"/>
               </a:rPr>
-              <a:t>인사 데이터를 AI에 그대로 노출하지 않고 안전하게 활용하기</a:t>
+              <a:t>인사 데이터를 AI에 노출하지 않고 안전하게 활용하는 방법</a:t>
             </a:r>
           </a:p>
         </p:txBody>
@@ -3468,7 +3466,7 @@
                 </a:solidFill>
                 <a:latin typeface="Calibri"/>
               </a:rPr>
-              <a:t>신원은 가리고, 숫자는 살린다</a:t>
+              <a:t>식별자는 토큰화, 숫자는 원본 유지</a:t>
             </a:r>
           </a:p>
         </p:txBody>
@@ -3863,7 +3861,7 @@
                 </a:solidFill>
                 <a:latin typeface="Calibri"/>
               </a:rPr>
-              <a:t>세 단계로 끝납니다</a:t>
+              <a:t>세 단계 처리</a:t>
             </a:r>
           </a:p>
         </p:txBody>
@@ -4415,7 +4413,7 @@
                 </a:solidFill>
                 <a:latin typeface="Calibri"/>
               </a:rPr>
-              <a:t>작업본은 토큰, 최종본만 실명</a:t>
+              <a:t>작업본은 토큰, 최종본은 실명</a:t>
             </a:r>
           </a:p>
         </p:txBody>
@@ -4978,7 +4976,7 @@
         <p:spPr>
           <a:xfrm>
             <a:off x="0" y="0"/>
-            <a:ext cx="12191695" cy="914400"/>
+            <a:ext cx="12191695" cy="6858000"/>
           </a:xfrm>
           <a:prstGeom prst="rect">
             <a:avLst/>
@@ -5015,98 +5013,20 @@
       </p:sp>
       <p:sp>
         <p:nvSpPr>
-          <p:cNvPr id="3" name="TextBox 2"/>
-          <p:cNvSpPr txBox="1"/>
-          <p:nvPr/>
-        </p:nvSpPr>
-        <p:spPr>
-          <a:xfrm>
-            <a:off x="640080" y="118872"/>
-            <a:ext cx="8168335" cy="219456"/>
-          </a:xfrm>
-          <a:prstGeom prst="rect">
-            <a:avLst/>
-          </a:prstGeom>
-          <a:noFill/>
-        </p:spPr>
-        <p:txBody>
-          <a:bodyPr wrap="square" anchor="t" lIns="0" rIns="0" tIns="0" bIns="0">
-            <a:spAutoFit/>
-          </a:bodyPr>
-          <a:lstStyle/>
-          <a:p>
-            <a:pPr algn="l">
-              <a:lnSpc>
-                <a:spcPct val="105000"/>
-              </a:lnSpc>
-            </a:pPr>
-            <a:r>
-              <a:rPr sz="1100" b="1" i="0">
-                <a:solidFill>
-                  <a:srgbClr val="FFFFFF"/>
-                </a:solidFill>
-                <a:latin typeface="Calibri"/>
-              </a:rPr>
-              <a:t>검증 결과</a:t>
-            </a:r>
-          </a:p>
-        </p:txBody>
-      </p:sp>
-      <p:sp>
-        <p:nvSpPr>
-          <p:cNvPr id="4" name="TextBox 3"/>
-          <p:cNvSpPr txBox="1"/>
-          <p:nvPr/>
-        </p:nvSpPr>
-        <p:spPr>
-          <a:xfrm>
-            <a:off x="640080" y="347472"/>
-            <a:ext cx="8168335" cy="493776"/>
-          </a:xfrm>
-          <a:prstGeom prst="rect">
-            <a:avLst/>
-          </a:prstGeom>
-          <a:noFill/>
-        </p:spPr>
-        <p:txBody>
-          <a:bodyPr wrap="square" anchor="t" lIns="0" rIns="0" tIns="0" bIns="0">
-            <a:spAutoFit/>
-          </a:bodyPr>
-          <a:lstStyle/>
-          <a:p>
-            <a:pPr algn="l">
-              <a:lnSpc>
-                <a:spcPct val="105000"/>
-              </a:lnSpc>
-            </a:pPr>
-            <a:r>
-              <a:rPr sz="3000" b="1" i="0">
-                <a:solidFill>
-                  <a:srgbClr val="FFFFFF"/>
-                </a:solidFill>
-                <a:latin typeface="Calibri"/>
-              </a:rPr>
-              <a:t>통계도, 개인별 업무도 — 누출 없이 둘 다</a:t>
-            </a:r>
-          </a:p>
-        </p:txBody>
-      </p:sp>
-      <p:sp>
-        <p:nvSpPr>
-          <p:cNvPr id="5" name="Rectangle 4"/>
+          <p:cNvPr id="3" name="Rectangle 2"/>
           <p:cNvSpPr/>
           <p:nvPr/>
         </p:nvSpPr>
         <p:spPr>
           <a:xfrm>
-            <a:off x="640080" y="2103120"/>
-            <a:ext cx="2453563" cy="2560320"/>
+            <a:off x="0" y="6492240"/>
+            <a:ext cx="12191695" cy="365760"/>
           </a:xfrm>
           <a:prstGeom prst="rect">
             <a:avLst/>
           </a:prstGeom>
           <a:solidFill>
-            <a:srgbClr val="F2F2F2"/>
+            <a:srgbClr val="2F5597"/>
           </a:solidFill>
           <a:ln>
             <a:noFill/>
@@ -5137,58 +5057,14 @@
       </p:sp>
       <p:sp>
         <p:nvSpPr>
-          <p:cNvPr id="6" name="Rectangle 5"/>
-          <p:cNvSpPr/>
-          <p:nvPr/>
-        </p:nvSpPr>
-        <p:spPr>
-          <a:xfrm>
-            <a:off x="640080" y="2103120"/>
-            <a:ext cx="2453563" cy="109728"/>
-          </a:xfrm>
-          <a:prstGeom prst="rect">
-            <a:avLst/>
-          </a:prstGeom>
-          <a:solidFill>
-            <a:srgbClr val="2F5597"/>
-          </a:solidFill>
-          <a:ln>
-            <a:noFill/>
-          </a:ln>
-          <a:effectLst/>
-        </p:spPr>
-        <p:style>
-          <a:lnRef idx="1">
-            <a:schemeClr val="accent1"/>
-          </a:lnRef>
-          <a:fillRef idx="3">
-            <a:schemeClr val="accent1"/>
-          </a:fillRef>
-          <a:effectRef idx="2">
-            <a:schemeClr val="accent1"/>
-          </a:effectRef>
-          <a:fontRef idx="minor">
-            <a:schemeClr val="lt1"/>
-          </a:fontRef>
-        </p:style>
-        <p:txBody>
-          <a:bodyPr rtlCol="0" anchor="ctr"/>
-          <a:lstStyle/>
-          <a:p>
-            <a:pPr algn="ctr"/>
-          </a:p>
-        </p:txBody>
-      </p:sp>
-      <p:sp>
-        <p:nvSpPr>
-          <p:cNvPr id="7" name="TextBox 6"/>
+          <p:cNvPr id="4" name="TextBox 3"/>
           <p:cNvSpPr txBox="1"/>
           <p:nvPr/>
         </p:nvSpPr>
         <p:spPr>
           <a:xfrm>
-            <a:off x="640080" y="2560320"/>
-            <a:ext cx="2453563" cy="1005840"/>
+            <a:off x="640080" y="2377440"/>
+            <a:ext cx="10911535" cy="1463040"/>
           </a:xfrm>
           <a:prstGeom prst="rect">
             <a:avLst/>
@@ -5207,1363 +5083,13 @@
               </a:lnSpc>
             </a:pPr>
             <a:r>
-              <a:rPr sz="4800" b="1" i="0">
-                <a:solidFill>
-                  <a:srgbClr val="111111"/>
+              <a:rPr sz="5000" b="1" i="0">
+                <a:solidFill>
+                  <a:srgbClr val="FFFFFF"/>
                 </a:solidFill>
                 <a:latin typeface="Calibri"/>
               </a:rPr>
-              <a:t>0건</a:t>
-            </a:r>
-          </a:p>
-        </p:txBody>
-      </p:sp>
-      <p:sp>
-        <p:nvSpPr>
-          <p:cNvPr id="8" name="TextBox 7"/>
-          <p:cNvSpPr txBox="1"/>
-          <p:nvPr/>
-        </p:nvSpPr>
-        <p:spPr>
-          <a:xfrm>
-            <a:off x="640080" y="3611880"/>
-            <a:ext cx="2453563" cy="457200"/>
-          </a:xfrm>
-          <a:prstGeom prst="rect">
-            <a:avLst/>
-          </a:prstGeom>
-          <a:noFill/>
-        </p:spPr>
-        <p:txBody>
-          <a:bodyPr wrap="square" anchor="t" lIns="0" rIns="0" tIns="0" bIns="0">
-            <a:spAutoFit/>
-          </a:bodyPr>
-          <a:lstStyle/>
-          <a:p>
-            <a:pPr algn="ctr">
-              <a:lnSpc>
-                <a:spcPct val="105000"/>
-              </a:lnSpc>
-            </a:pPr>
-            <a:r>
-              <a:rPr sz="2200" b="1" i="0">
-                <a:solidFill>
-                  <a:srgbClr val="1A1A1A"/>
-                </a:solidFill>
-                <a:latin typeface="Calibri"/>
-              </a:rPr>
-              <a:t>식별자 누출</a:t>
-            </a:r>
-          </a:p>
-        </p:txBody>
-      </p:sp>
-      <p:sp>
-        <p:nvSpPr>
-          <p:cNvPr id="9" name="TextBox 8"/>
-          <p:cNvSpPr txBox="1"/>
-          <p:nvPr/>
-        </p:nvSpPr>
-        <p:spPr>
-          <a:xfrm>
-            <a:off x="822960" y="4023360"/>
-            <a:ext cx="2087803" cy="548640"/>
-          </a:xfrm>
-          <a:prstGeom prst="rect">
-            <a:avLst/>
-          </a:prstGeom>
-          <a:noFill/>
-        </p:spPr>
-        <p:txBody>
-          <a:bodyPr wrap="square" anchor="t" lIns="0" rIns="0" tIns="0" bIns="0">
-            <a:spAutoFit/>
-          </a:bodyPr>
-          <a:lstStyle/>
-          <a:p>
-            <a:pPr algn="ctr">
-              <a:lnSpc>
-                <a:spcPct val="100000"/>
-              </a:lnSpc>
-            </a:pPr>
-            <a:r>
-              <a:rPr sz="1200" b="0" i="0">
-                <a:solidFill>
-                  <a:srgbClr val="7F7F7F"/>
-                </a:solidFill>
-                <a:latin typeface="Calibri"/>
-              </a:rPr>
-              <a:t>작업 내내</a:t>
-            </a:r>
-          </a:p>
-        </p:txBody>
-      </p:sp>
-      <p:sp>
-        <p:nvSpPr>
-          <p:cNvPr id="10" name="Rectangle 9"/>
-          <p:cNvSpPr/>
-          <p:nvPr/>
-        </p:nvSpPr>
-        <p:spPr>
-          <a:xfrm>
-            <a:off x="3459403" y="2103120"/>
-            <a:ext cx="2453563" cy="2560320"/>
-          </a:xfrm>
-          <a:prstGeom prst="rect">
-            <a:avLst/>
-          </a:prstGeom>
-          <a:solidFill>
-            <a:srgbClr val="F2F2F2"/>
-          </a:solidFill>
-          <a:ln>
-            <a:noFill/>
-          </a:ln>
-          <a:effectLst/>
-        </p:spPr>
-        <p:style>
-          <a:lnRef idx="1">
-            <a:schemeClr val="accent1"/>
-          </a:lnRef>
-          <a:fillRef idx="3">
-            <a:schemeClr val="accent1"/>
-          </a:fillRef>
-          <a:effectRef idx="2">
-            <a:schemeClr val="accent1"/>
-          </a:effectRef>
-          <a:fontRef idx="minor">
-            <a:schemeClr val="lt1"/>
-          </a:fontRef>
-        </p:style>
-        <p:txBody>
-          <a:bodyPr rtlCol="0" anchor="ctr"/>
-          <a:lstStyle/>
-          <a:p>
-            <a:pPr algn="ctr"/>
-          </a:p>
-        </p:txBody>
-      </p:sp>
-      <p:sp>
-        <p:nvSpPr>
-          <p:cNvPr id="11" name="Rectangle 10"/>
-          <p:cNvSpPr/>
-          <p:nvPr/>
-        </p:nvSpPr>
-        <p:spPr>
-          <a:xfrm>
-            <a:off x="3459403" y="2103120"/>
-            <a:ext cx="2453563" cy="109728"/>
-          </a:xfrm>
-          <a:prstGeom prst="rect">
-            <a:avLst/>
-          </a:prstGeom>
-          <a:solidFill>
-            <a:srgbClr val="2F5597"/>
-          </a:solidFill>
-          <a:ln>
-            <a:noFill/>
-          </a:ln>
-          <a:effectLst/>
-        </p:spPr>
-        <p:style>
-          <a:lnRef idx="1">
-            <a:schemeClr val="accent1"/>
-          </a:lnRef>
-          <a:fillRef idx="3">
-            <a:schemeClr val="accent1"/>
-          </a:fillRef>
-          <a:effectRef idx="2">
-            <a:schemeClr val="accent1"/>
-          </a:effectRef>
-          <a:fontRef idx="minor">
-            <a:schemeClr val="lt1"/>
-          </a:fontRef>
-        </p:style>
-        <p:txBody>
-          <a:bodyPr rtlCol="0" anchor="ctr"/>
-          <a:lstStyle/>
-          <a:p>
-            <a:pPr algn="ctr"/>
-          </a:p>
-        </p:txBody>
-      </p:sp>
-      <p:sp>
-        <p:nvSpPr>
-          <p:cNvPr id="12" name="TextBox 11"/>
-          <p:cNvSpPr txBox="1"/>
-          <p:nvPr/>
-        </p:nvSpPr>
-        <p:spPr>
-          <a:xfrm>
-            <a:off x="3459403" y="2560320"/>
-            <a:ext cx="2453563" cy="1005840"/>
-          </a:xfrm>
-          <a:prstGeom prst="rect">
-            <a:avLst/>
-          </a:prstGeom>
-          <a:noFill/>
-        </p:spPr>
-        <p:txBody>
-          <a:bodyPr wrap="square" anchor="t" lIns="0" rIns="0" tIns="0" bIns="0">
-            <a:spAutoFit/>
-          </a:bodyPr>
-          <a:lstStyle/>
-          <a:p>
-            <a:pPr algn="ctr">
-              <a:lnSpc>
-                <a:spcPct val="105000"/>
-              </a:lnSpc>
-            </a:pPr>
-            <a:r>
-              <a:rPr sz="4800" b="1" i="0">
-                <a:solidFill>
-                  <a:srgbClr val="111111"/>
-                </a:solidFill>
-                <a:latin typeface="Calibri"/>
-              </a:rPr>
-              <a:t>24/24</a:t>
-            </a:r>
-          </a:p>
-        </p:txBody>
-      </p:sp>
-      <p:sp>
-        <p:nvSpPr>
-          <p:cNvPr id="13" name="TextBox 12"/>
-          <p:cNvSpPr txBox="1"/>
-          <p:nvPr/>
-        </p:nvSpPr>
-        <p:spPr>
-          <a:xfrm>
-            <a:off x="3459403" y="3611880"/>
-            <a:ext cx="2453563" cy="457200"/>
-          </a:xfrm>
-          <a:prstGeom prst="rect">
-            <a:avLst/>
-          </a:prstGeom>
-          <a:noFill/>
-        </p:spPr>
-        <p:txBody>
-          <a:bodyPr wrap="square" anchor="t" lIns="0" rIns="0" tIns="0" bIns="0">
-            <a:spAutoFit/>
-          </a:bodyPr>
-          <a:lstStyle/>
-          <a:p>
-            <a:pPr algn="ctr">
-              <a:lnSpc>
-                <a:spcPct val="105000"/>
-              </a:lnSpc>
-            </a:pPr>
-            <a:r>
-              <a:rPr sz="2200" b="1" i="0">
-                <a:solidFill>
-                  <a:srgbClr val="1A1A1A"/>
-                </a:solidFill>
-                <a:latin typeface="Calibri"/>
-              </a:rPr>
-              <a:t>시나리오 통과</a:t>
-            </a:r>
-          </a:p>
-        </p:txBody>
-      </p:sp>
-      <p:sp>
-        <p:nvSpPr>
-          <p:cNvPr id="14" name="TextBox 13"/>
-          <p:cNvSpPr txBox="1"/>
-          <p:nvPr/>
-        </p:nvSpPr>
-        <p:spPr>
-          <a:xfrm>
-            <a:off x="3642283" y="4023360"/>
-            <a:ext cx="2087803" cy="548640"/>
-          </a:xfrm>
-          <a:prstGeom prst="rect">
-            <a:avLst/>
-          </a:prstGeom>
-          <a:noFill/>
-        </p:spPr>
-        <p:txBody>
-          <a:bodyPr wrap="square" anchor="t" lIns="0" rIns="0" tIns="0" bIns="0">
-            <a:spAutoFit/>
-          </a:bodyPr>
-          <a:lstStyle/>
-          <a:p>
-            <a:pPr algn="ctr">
-              <a:lnSpc>
-                <a:spcPct val="100000"/>
-              </a:lnSpc>
-            </a:pPr>
-            <a:r>
-              <a:rPr sz="1200" b="0" i="0">
-                <a:solidFill>
-                  <a:srgbClr val="7F7F7F"/>
-                </a:solidFill>
-                <a:latin typeface="Calibri"/>
-              </a:rPr>
-              <a:t>통계 + HR 업무</a:t>
-            </a:r>
-          </a:p>
-        </p:txBody>
-      </p:sp>
-      <p:sp>
-        <p:nvSpPr>
-          <p:cNvPr id="15" name="Rectangle 14"/>
-          <p:cNvSpPr/>
-          <p:nvPr/>
-        </p:nvSpPr>
-        <p:spPr>
-          <a:xfrm>
-            <a:off x="6278727" y="2103120"/>
-            <a:ext cx="2453563" cy="2560320"/>
-          </a:xfrm>
-          <a:prstGeom prst="rect">
-            <a:avLst/>
-          </a:prstGeom>
-          <a:solidFill>
-            <a:srgbClr val="F2F2F2"/>
-          </a:solidFill>
-          <a:ln>
-            <a:noFill/>
-          </a:ln>
-          <a:effectLst/>
-        </p:spPr>
-        <p:style>
-          <a:lnRef idx="1">
-            <a:schemeClr val="accent1"/>
-          </a:lnRef>
-          <a:fillRef idx="3">
-            <a:schemeClr val="accent1"/>
-          </a:fillRef>
-          <a:effectRef idx="2">
-            <a:schemeClr val="accent1"/>
-          </a:effectRef>
-          <a:fontRef idx="minor">
-            <a:schemeClr val="lt1"/>
-          </a:fontRef>
-        </p:style>
-        <p:txBody>
-          <a:bodyPr rtlCol="0" anchor="ctr"/>
-          <a:lstStyle/>
-          <a:p>
-            <a:pPr algn="ctr"/>
-          </a:p>
-        </p:txBody>
-      </p:sp>
-      <p:sp>
-        <p:nvSpPr>
-          <p:cNvPr id="16" name="Rectangle 15"/>
-          <p:cNvSpPr/>
-          <p:nvPr/>
-        </p:nvSpPr>
-        <p:spPr>
-          <a:xfrm>
-            <a:off x="6278727" y="2103120"/>
-            <a:ext cx="2453563" cy="109728"/>
-          </a:xfrm>
-          <a:prstGeom prst="rect">
-            <a:avLst/>
-          </a:prstGeom>
-          <a:solidFill>
-            <a:srgbClr val="2F5597"/>
-          </a:solidFill>
-          <a:ln>
-            <a:noFill/>
-          </a:ln>
-          <a:effectLst/>
-        </p:spPr>
-        <p:style>
-          <a:lnRef idx="1">
-            <a:schemeClr val="accent1"/>
-          </a:lnRef>
-          <a:fillRef idx="3">
-            <a:schemeClr val="accent1"/>
-          </a:fillRef>
-          <a:effectRef idx="2">
-            <a:schemeClr val="accent1"/>
-          </a:effectRef>
-          <a:fontRef idx="minor">
-            <a:schemeClr val="lt1"/>
-          </a:fontRef>
-        </p:style>
-        <p:txBody>
-          <a:bodyPr rtlCol="0" anchor="ctr"/>
-          <a:lstStyle/>
-          <a:p>
-            <a:pPr algn="ctr"/>
-          </a:p>
-        </p:txBody>
-      </p:sp>
-      <p:sp>
-        <p:nvSpPr>
-          <p:cNvPr id="17" name="TextBox 16"/>
-          <p:cNvSpPr txBox="1"/>
-          <p:nvPr/>
-        </p:nvSpPr>
-        <p:spPr>
-          <a:xfrm>
-            <a:off x="6278727" y="2560320"/>
-            <a:ext cx="2453563" cy="1005840"/>
-          </a:xfrm>
-          <a:prstGeom prst="rect">
-            <a:avLst/>
-          </a:prstGeom>
-          <a:noFill/>
-        </p:spPr>
-        <p:txBody>
-          <a:bodyPr wrap="square" anchor="t" lIns="0" rIns="0" tIns="0" bIns="0">
-            <a:spAutoFit/>
-          </a:bodyPr>
-          <a:lstStyle/>
-          <a:p>
-            <a:pPr algn="ctr">
-              <a:lnSpc>
-                <a:spcPct val="105000"/>
-              </a:lnSpc>
-            </a:pPr>
-            <a:r>
-              <a:rPr sz="4800" b="1" i="0">
-                <a:solidFill>
-                  <a:srgbClr val="111111"/>
-                </a:solidFill>
-                <a:latin typeface="Calibri"/>
-              </a:rPr>
-              <a:t>100%</a:t>
-            </a:r>
-          </a:p>
-        </p:txBody>
-      </p:sp>
-      <p:sp>
-        <p:nvSpPr>
-          <p:cNvPr id="18" name="TextBox 17"/>
-          <p:cNvSpPr txBox="1"/>
-          <p:nvPr/>
-        </p:nvSpPr>
-        <p:spPr>
-          <a:xfrm>
-            <a:off x="6278727" y="3611880"/>
-            <a:ext cx="2453563" cy="457200"/>
-          </a:xfrm>
-          <a:prstGeom prst="rect">
-            <a:avLst/>
-          </a:prstGeom>
-          <a:noFill/>
-        </p:spPr>
-        <p:txBody>
-          <a:bodyPr wrap="square" anchor="t" lIns="0" rIns="0" tIns="0" bIns="0">
-            <a:spAutoFit/>
-          </a:bodyPr>
-          <a:lstStyle/>
-          <a:p>
-            <a:pPr algn="ctr">
-              <a:lnSpc>
-                <a:spcPct val="105000"/>
-              </a:lnSpc>
-            </a:pPr>
-            <a:r>
-              <a:rPr sz="2200" b="1" i="0">
-                <a:solidFill>
-                  <a:srgbClr val="1A1A1A"/>
-                </a:solidFill>
-                <a:latin typeface="Calibri"/>
-              </a:rPr>
-              <a:t>통계 정확도</a:t>
-            </a:r>
-          </a:p>
-        </p:txBody>
-      </p:sp>
-      <p:sp>
-        <p:nvSpPr>
-          <p:cNvPr id="19" name="TextBox 18"/>
-          <p:cNvSpPr txBox="1"/>
-          <p:nvPr/>
-        </p:nvSpPr>
-        <p:spPr>
-          <a:xfrm>
-            <a:off x="6461607" y="4023360"/>
-            <a:ext cx="2087803" cy="548640"/>
-          </a:xfrm>
-          <a:prstGeom prst="rect">
-            <a:avLst/>
-          </a:prstGeom>
-          <a:noFill/>
-        </p:spPr>
-        <p:txBody>
-          <a:bodyPr wrap="square" anchor="t" lIns="0" rIns="0" tIns="0" bIns="0">
-            <a:spAutoFit/>
-          </a:bodyPr>
-          <a:lstStyle/>
-          <a:p>
-            <a:pPr algn="ctr">
-              <a:lnSpc>
-                <a:spcPct val="100000"/>
-              </a:lnSpc>
-            </a:pPr>
-            <a:r>
-              <a:rPr sz="1200" b="0" i="0">
-                <a:solidFill>
-                  <a:srgbClr val="7F7F7F"/>
-                </a:solidFill>
-                <a:latin typeface="Calibri"/>
-              </a:rPr>
-              <a:t>비식별 파일서 직접 산출</a:t>
-            </a:r>
-          </a:p>
-        </p:txBody>
-      </p:sp>
-      <p:sp>
-        <p:nvSpPr>
-          <p:cNvPr id="20" name="Rectangle 19"/>
-          <p:cNvSpPr/>
-          <p:nvPr/>
-        </p:nvSpPr>
-        <p:spPr>
-          <a:xfrm>
-            <a:off x="9098051" y="2103120"/>
-            <a:ext cx="2453563" cy="2560320"/>
-          </a:xfrm>
-          <a:prstGeom prst="rect">
-            <a:avLst/>
-          </a:prstGeom>
-          <a:solidFill>
-            <a:srgbClr val="F2F2F2"/>
-          </a:solidFill>
-          <a:ln>
-            <a:noFill/>
-          </a:ln>
-          <a:effectLst/>
-        </p:spPr>
-        <p:style>
-          <a:lnRef idx="1">
-            <a:schemeClr val="accent1"/>
-          </a:lnRef>
-          <a:fillRef idx="3">
-            <a:schemeClr val="accent1"/>
-          </a:fillRef>
-          <a:effectRef idx="2">
-            <a:schemeClr val="accent1"/>
-          </a:effectRef>
-          <a:fontRef idx="minor">
-            <a:schemeClr val="lt1"/>
-          </a:fontRef>
-        </p:style>
-        <p:txBody>
-          <a:bodyPr rtlCol="0" anchor="ctr"/>
-          <a:lstStyle/>
-          <a:p>
-            <a:pPr algn="ctr"/>
-          </a:p>
-        </p:txBody>
-      </p:sp>
-      <p:sp>
-        <p:nvSpPr>
-          <p:cNvPr id="21" name="Rectangle 20"/>
-          <p:cNvSpPr/>
-          <p:nvPr/>
-        </p:nvSpPr>
-        <p:spPr>
-          <a:xfrm>
-            <a:off x="9098051" y="2103120"/>
-            <a:ext cx="2453563" cy="109728"/>
-          </a:xfrm>
-          <a:prstGeom prst="rect">
-            <a:avLst/>
-          </a:prstGeom>
-          <a:solidFill>
-            <a:srgbClr val="2F5597"/>
-          </a:solidFill>
-          <a:ln>
-            <a:noFill/>
-          </a:ln>
-          <a:effectLst/>
-        </p:spPr>
-        <p:style>
-          <a:lnRef idx="1">
-            <a:schemeClr val="accent1"/>
-          </a:lnRef>
-          <a:fillRef idx="3">
-            <a:schemeClr val="accent1"/>
-          </a:fillRef>
-          <a:effectRef idx="2">
-            <a:schemeClr val="accent1"/>
-          </a:effectRef>
-          <a:fontRef idx="minor">
-            <a:schemeClr val="lt1"/>
-          </a:fontRef>
-        </p:style>
-        <p:txBody>
-          <a:bodyPr rtlCol="0" anchor="ctr"/>
-          <a:lstStyle/>
-          <a:p>
-            <a:pPr algn="ctr"/>
-          </a:p>
-        </p:txBody>
-      </p:sp>
-      <p:sp>
-        <p:nvSpPr>
-          <p:cNvPr id="22" name="TextBox 21"/>
-          <p:cNvSpPr txBox="1"/>
-          <p:nvPr/>
-        </p:nvSpPr>
-        <p:spPr>
-          <a:xfrm>
-            <a:off x="9098051" y="2560320"/>
-            <a:ext cx="2453563" cy="1005840"/>
-          </a:xfrm>
-          <a:prstGeom prst="rect">
-            <a:avLst/>
-          </a:prstGeom>
-          <a:noFill/>
-        </p:spPr>
-        <p:txBody>
-          <a:bodyPr wrap="square" anchor="t" lIns="0" rIns="0" tIns="0" bIns="0">
-            <a:spAutoFit/>
-          </a:bodyPr>
-          <a:lstStyle/>
-          <a:p>
-            <a:pPr algn="ctr">
-              <a:lnSpc>
-                <a:spcPct val="105000"/>
-              </a:lnSpc>
-            </a:pPr>
-            <a:r>
-              <a:rPr sz="4800" b="1" i="0">
-                <a:solidFill>
-                  <a:srgbClr val="111111"/>
-                </a:solidFill>
-                <a:latin typeface="Calibri"/>
-              </a:rPr>
-              <a:t>250명+</a:t>
-            </a:r>
-          </a:p>
-        </p:txBody>
-      </p:sp>
-      <p:sp>
-        <p:nvSpPr>
-          <p:cNvPr id="23" name="TextBox 22"/>
-          <p:cNvSpPr txBox="1"/>
-          <p:nvPr/>
-        </p:nvSpPr>
-        <p:spPr>
-          <a:xfrm>
-            <a:off x="9098051" y="3611880"/>
-            <a:ext cx="2453563" cy="457200"/>
-          </a:xfrm>
-          <a:prstGeom prst="rect">
-            <a:avLst/>
-          </a:prstGeom>
-          <a:noFill/>
-        </p:spPr>
-        <p:txBody>
-          <a:bodyPr wrap="square" anchor="t" lIns="0" rIns="0" tIns="0" bIns="0">
-            <a:spAutoFit/>
-          </a:bodyPr>
-          <a:lstStyle/>
-          <a:p>
-            <a:pPr algn="ctr">
-              <a:lnSpc>
-                <a:spcPct val="105000"/>
-              </a:lnSpc>
-            </a:pPr>
-            <a:r>
-              <a:rPr sz="2200" b="1" i="0">
-                <a:solidFill>
-                  <a:srgbClr val="1A1A1A"/>
-                </a:solidFill>
-                <a:latin typeface="Calibri"/>
-              </a:rPr>
-              <a:t>검증 데이터</a:t>
-            </a:r>
-          </a:p>
-        </p:txBody>
-      </p:sp>
-      <p:sp>
-        <p:nvSpPr>
-          <p:cNvPr id="24" name="TextBox 23"/>
-          <p:cNvSpPr txBox="1"/>
-          <p:nvPr/>
-        </p:nvSpPr>
-        <p:spPr>
-          <a:xfrm>
-            <a:off x="9280931" y="4023360"/>
-            <a:ext cx="2087803" cy="548640"/>
-          </a:xfrm>
-          <a:prstGeom prst="rect">
-            <a:avLst/>
-          </a:prstGeom>
-          <a:noFill/>
-        </p:spPr>
-        <p:txBody>
-          <a:bodyPr wrap="square" anchor="t" lIns="0" rIns="0" tIns="0" bIns="0">
-            <a:spAutoFit/>
-          </a:bodyPr>
-          <a:lstStyle/>
-          <a:p>
-            <a:pPr algn="ctr">
-              <a:lnSpc>
-                <a:spcPct val="100000"/>
-              </a:lnSpc>
-            </a:pPr>
-            <a:r>
-              <a:rPr sz="1200" b="0" i="0">
-                <a:solidFill>
-                  <a:srgbClr val="7F7F7F"/>
-                </a:solidFill>
-                <a:latin typeface="Calibri"/>
-              </a:rPr>
-              <a:t>다른 규모·문서 포함</a:t>
-            </a:r>
-          </a:p>
-        </p:txBody>
-      </p:sp>
-      <p:sp>
-        <p:nvSpPr>
-          <p:cNvPr id="25" name="TextBox 24"/>
-          <p:cNvSpPr txBox="1"/>
-          <p:nvPr/>
-        </p:nvSpPr>
-        <p:spPr>
-          <a:xfrm>
-            <a:off x="640080" y="6400800"/>
-            <a:ext cx="9997135" cy="274320"/>
-          </a:xfrm>
-          <a:prstGeom prst="rect">
-            <a:avLst/>
-          </a:prstGeom>
-          <a:noFill/>
-        </p:spPr>
-        <p:txBody>
-          <a:bodyPr wrap="square" anchor="t" lIns="0" rIns="0" tIns="0" bIns="0">
-            <a:spAutoFit/>
-          </a:bodyPr>
-          <a:lstStyle/>
-          <a:p>
-            <a:pPr algn="l">
-              <a:lnSpc>
-                <a:spcPct val="105000"/>
-              </a:lnSpc>
-            </a:pPr>
-            <a:r>
-              <a:rPr sz="1000" b="0" i="0">
-                <a:solidFill>
-                  <a:srgbClr val="7F7F7F"/>
-                </a:solidFill>
-                <a:latin typeface="Calibri"/>
-              </a:rPr>
-              <a:t>대외비 · Confidential · 인사팀 대상 설명자료</a:t>
-            </a:r>
-          </a:p>
-        </p:txBody>
-      </p:sp>
-      <p:sp>
-        <p:nvSpPr>
-          <p:cNvPr id="26" name="TextBox 25"/>
-          <p:cNvSpPr txBox="1"/>
-          <p:nvPr/>
-        </p:nvSpPr>
-        <p:spPr>
-          <a:xfrm>
-            <a:off x="10454335" y="6291072"/>
-            <a:ext cx="1097280" cy="384048"/>
-          </a:xfrm>
-          <a:prstGeom prst="rect">
-            <a:avLst/>
-          </a:prstGeom>
-          <a:noFill/>
-        </p:spPr>
-        <p:txBody>
-          <a:bodyPr wrap="square" anchor="t" lIns="0" rIns="0" tIns="0" bIns="0">
-            <a:spAutoFit/>
-          </a:bodyPr>
-          <a:lstStyle/>
-          <a:p>
-            <a:pPr algn="r">
-              <a:lnSpc>
-                <a:spcPct val="105000"/>
-              </a:lnSpc>
-            </a:pPr>
-            <a:r>
-              <a:rPr sz="1600" b="0" i="0">
-                <a:solidFill>
-                  <a:srgbClr val="7F7F7F"/>
-                </a:solidFill>
-                <a:latin typeface="Calibri"/>
-              </a:rPr>
-              <a:t>5</a:t>
-            </a:r>
-          </a:p>
-        </p:txBody>
-      </p:sp>
-      <p:sp>
-        <p:nvSpPr>
-          <p:cNvPr id="27" name="TextBox 26"/>
-          <p:cNvSpPr txBox="1"/>
-          <p:nvPr/>
-        </p:nvSpPr>
-        <p:spPr>
-          <a:xfrm>
-            <a:off x="8808415" y="182880"/>
-            <a:ext cx="2743200" cy="548640"/>
-          </a:xfrm>
-          <a:prstGeom prst="rect">
-            <a:avLst/>
-          </a:prstGeom>
-          <a:noFill/>
-        </p:spPr>
-        <p:txBody>
-          <a:bodyPr wrap="square" anchor="t" lIns="0" rIns="0" tIns="0" bIns="0">
-            <a:spAutoFit/>
-          </a:bodyPr>
-          <a:lstStyle/>
-          <a:p>
-            <a:pPr algn="r">
-              <a:lnSpc>
-                <a:spcPct val="105000"/>
-              </a:lnSpc>
-            </a:pPr>
-            <a:r>
-              <a:rPr sz="1800" b="1" i="0">
-                <a:solidFill>
-                  <a:srgbClr val="FFFFFF"/>
-                </a:solidFill>
-                <a:latin typeface="Calibri"/>
-              </a:rPr>
-              <a:t>Confidential</a:t>
-            </a:r>
-          </a:p>
-        </p:txBody>
-      </p:sp>
-    </p:spTree>
-  </p:cSld>
-  <p:clrMapOvr>
-    <a:masterClrMapping/>
-  </p:clrMapOvr>
-</p:sld>
-</file>
-
-<file path=ppt/slides/slide6.xml><?xml version="1.0" encoding="utf-8"?>
-<p:sld xmlns:a="http://schemas.openxmlformats.org/drawingml/2006/main" xmlns:p="http://schemas.openxmlformats.org/presentationml/2006/main" xmlns:r="http://schemas.openxmlformats.org/officeDocument/2006/relationships">
-  <p:cSld>
-    <p:spTree>
-      <p:nvGrpSpPr>
-        <p:cNvPr id="1" name=""/>
-        <p:cNvGrpSpPr/>
-        <p:nvPr/>
-      </p:nvGrpSpPr>
-      <p:grpSpPr/>
-      <p:sp>
-        <p:nvSpPr>
-          <p:cNvPr id="2" name="Rectangle 1"/>
-          <p:cNvSpPr/>
-          <p:nvPr/>
-        </p:nvSpPr>
-        <p:spPr>
-          <a:xfrm>
-            <a:off x="0" y="0"/>
-            <a:ext cx="12191695" cy="914400"/>
-          </a:xfrm>
-          <a:prstGeom prst="rect">
-            <a:avLst/>
-          </a:prstGeom>
-          <a:solidFill>
-            <a:srgbClr val="111111"/>
-          </a:solidFill>
-          <a:ln>
-            <a:noFill/>
-          </a:ln>
-          <a:effectLst/>
-        </p:spPr>
-        <p:style>
-          <a:lnRef idx="1">
-            <a:schemeClr val="accent1"/>
-          </a:lnRef>
-          <a:fillRef idx="3">
-            <a:schemeClr val="accent1"/>
-          </a:fillRef>
-          <a:effectRef idx="2">
-            <a:schemeClr val="accent1"/>
-          </a:effectRef>
-          <a:fontRef idx="minor">
-            <a:schemeClr val="lt1"/>
-          </a:fontRef>
-        </p:style>
-        <p:txBody>
-          <a:bodyPr rtlCol="0" anchor="ctr"/>
-          <a:lstStyle/>
-          <a:p>
-            <a:pPr algn="ctr"/>
-          </a:p>
-        </p:txBody>
-      </p:sp>
-      <p:sp>
-        <p:nvSpPr>
-          <p:cNvPr id="3" name="TextBox 2"/>
-          <p:cNvSpPr txBox="1"/>
-          <p:nvPr/>
-        </p:nvSpPr>
-        <p:spPr>
-          <a:xfrm>
-            <a:off x="640080" y="118872"/>
-            <a:ext cx="8168335" cy="219456"/>
-          </a:xfrm>
-          <a:prstGeom prst="rect">
-            <a:avLst/>
-          </a:prstGeom>
-          <a:noFill/>
-        </p:spPr>
-        <p:txBody>
-          <a:bodyPr wrap="square" anchor="t" lIns="0" rIns="0" tIns="0" bIns="0">
-            <a:spAutoFit/>
-          </a:bodyPr>
-          <a:lstStyle/>
-          <a:p>
-            <a:pPr algn="l">
-              <a:lnSpc>
-                <a:spcPct val="105000"/>
-              </a:lnSpc>
-            </a:pPr>
-            <a:r>
-              <a:rPr sz="1100" b="1" i="0">
-                <a:solidFill>
-                  <a:srgbClr val="FFFFFF"/>
-                </a:solidFill>
-                <a:latin typeface="Calibri"/>
-              </a:rPr>
-              <a:t>기대 효과 · 유의점</a:t>
-            </a:r>
-          </a:p>
-        </p:txBody>
-      </p:sp>
-      <p:sp>
-        <p:nvSpPr>
-          <p:cNvPr id="4" name="TextBox 3"/>
-          <p:cNvSpPr txBox="1"/>
-          <p:nvPr/>
-        </p:nvSpPr>
-        <p:spPr>
-          <a:xfrm>
-            <a:off x="640080" y="347472"/>
-            <a:ext cx="8168335" cy="493776"/>
-          </a:xfrm>
-          <a:prstGeom prst="rect">
-            <a:avLst/>
-          </a:prstGeom>
-          <a:noFill/>
-        </p:spPr>
-        <p:txBody>
-          <a:bodyPr wrap="square" anchor="t" lIns="0" rIns="0" tIns="0" bIns="0">
-            <a:spAutoFit/>
-          </a:bodyPr>
-          <a:lstStyle/>
-          <a:p>
-            <a:pPr algn="l">
-              <a:lnSpc>
-                <a:spcPct val="105000"/>
-              </a:lnSpc>
-            </a:pPr>
-            <a:r>
-              <a:rPr sz="3000" b="1" i="0">
-                <a:solidFill>
-                  <a:srgbClr val="FFFFFF"/>
-                </a:solidFill>
-                <a:latin typeface="Calibri"/>
-              </a:rPr>
-              <a:t>인사팀에게 좋은 점, 그리고 알아둘 점</a:t>
-            </a:r>
-          </a:p>
-        </p:txBody>
-      </p:sp>
-      <p:sp>
-        <p:nvSpPr>
-          <p:cNvPr id="5" name="TextBox 4"/>
-          <p:cNvSpPr txBox="1"/>
-          <p:nvPr/>
-        </p:nvSpPr>
-        <p:spPr>
-          <a:xfrm>
-            <a:off x="640080" y="1554480"/>
-            <a:ext cx="10911535" cy="640080"/>
-          </a:xfrm>
-          <a:prstGeom prst="rect">
-            <a:avLst/>
-          </a:prstGeom>
-          <a:noFill/>
-        </p:spPr>
-        <p:txBody>
-          <a:bodyPr wrap="square" anchor="t" lIns="0" rIns="0" tIns="0" bIns="0">
-            <a:spAutoFit/>
-          </a:bodyPr>
-          <a:lstStyle/>
-          <a:p>
-            <a:pPr algn="l">
-              <a:lnSpc>
-                <a:spcPct val="110000"/>
-              </a:lnSpc>
-            </a:pPr>
-            <a:r>
-              <a:rPr sz="2400" b="0" i="1">
-                <a:solidFill>
-                  <a:srgbClr val="595959"/>
-                </a:solidFill>
-                <a:latin typeface="Calibri"/>
-              </a:rPr>
-              <a:t>평소처럼 일하되, 신원은 가려진 채로.</a:t>
-            </a:r>
-          </a:p>
-        </p:txBody>
-      </p:sp>
-      <p:sp>
-        <p:nvSpPr>
-          <p:cNvPr id="6" name="TextBox 5"/>
-          <p:cNvSpPr txBox="1"/>
-          <p:nvPr/>
-        </p:nvSpPr>
-        <p:spPr>
-          <a:xfrm>
-            <a:off x="640080" y="2286000"/>
-            <a:ext cx="10911535" cy="3931920"/>
-          </a:xfrm>
-          <a:prstGeom prst="rect">
-            <a:avLst/>
-          </a:prstGeom>
-          <a:noFill/>
-        </p:spPr>
-        <p:txBody>
-          <a:bodyPr wrap="square" anchor="t" lIns="0" rIns="0" tIns="0" bIns="0">
-            <a:spAutoFit/>
-          </a:bodyPr>
-          <a:lstStyle/>
-          <a:p>
-            <a:pPr algn="l">
-              <a:lnSpc>
-                <a:spcPct val="110000"/>
-              </a:lnSpc>
-              <a:spcAft>
-                <a:spcPts val="1000"/>
-              </a:spcAft>
-            </a:pPr>
-            <a:r>
-              <a:rPr sz="2200" b="1" i="0">
-                <a:solidFill>
-                  <a:srgbClr val="1A1A1A"/>
-                </a:solidFill>
-                <a:latin typeface="Calibri"/>
-              </a:rPr>
-              <a:t>●  안전 — 식별자 AI 노출 0건 · 통계 가능 — 연봉·근태가 원본</a:t>
-            </a:r>
-          </a:p>
-          <a:p>
-            <a:pPr algn="l">
-              <a:lnSpc>
-                <a:spcPct val="110000"/>
-              </a:lnSpc>
-              <a:spcAft>
-                <a:spcPts val="1000"/>
-              </a:spcAft>
-            </a:pPr>
-            <a:r>
-              <a:rPr sz="2200" b="0" i="0">
-                <a:solidFill>
-                  <a:srgbClr val="1A1A1A"/>
-                </a:solidFill>
-                <a:latin typeface="Calibri"/>
-              </a:rPr>
-              <a:t>●  간편 — 키 없이 '비식별화 → 재식별' 두 단계 · 문서(.txt/.md)도 지원</a:t>
-            </a:r>
-          </a:p>
-          <a:p>
-            <a:pPr algn="l">
-              <a:lnSpc>
-                <a:spcPct val="110000"/>
-              </a:lnSpc>
-              <a:spcAft>
-                <a:spcPts val="1000"/>
-              </a:spcAft>
-            </a:pPr>
-            <a:r>
-              <a:rPr sz="2200" b="0" i="0">
-                <a:solidFill>
-                  <a:srgbClr val="1A1A1A"/>
-                </a:solidFill>
-                <a:latin typeface="Calibri"/>
-              </a:rPr>
-              <a:t>●  유의 — 숫자 값은 (이름과 분리된 채) 보입니다; 개별 숫자도 숨겨야 하면 집계값만 전달</a:t>
-            </a:r>
-          </a:p>
-          <a:p>
-            <a:pPr algn="l">
-              <a:lnSpc>
-                <a:spcPct val="110000"/>
-              </a:lnSpc>
-              <a:spcAft>
-                <a:spcPts val="1000"/>
-              </a:spcAft>
-            </a:pPr>
-            <a:r>
-              <a:rPr sz="2200" b="0" i="0">
-                <a:solidFill>
-                  <a:srgbClr val="1A1A1A"/>
-                </a:solidFill>
-                <a:latin typeface="Calibri"/>
-              </a:rPr>
-              <a:t>●  유의 — 복원 대응표(map)는 평문이라 원본처럼 안전 보관 필요</a:t>
-            </a:r>
-          </a:p>
-        </p:txBody>
-      </p:sp>
-      <p:sp>
-        <p:nvSpPr>
-          <p:cNvPr id="7" name="TextBox 6"/>
-          <p:cNvSpPr txBox="1"/>
-          <p:nvPr/>
-        </p:nvSpPr>
-        <p:spPr>
-          <a:xfrm>
-            <a:off x="640080" y="6400800"/>
-            <a:ext cx="9997135" cy="274320"/>
-          </a:xfrm>
-          <a:prstGeom prst="rect">
-            <a:avLst/>
-          </a:prstGeom>
-          <a:noFill/>
-        </p:spPr>
-        <p:txBody>
-          <a:bodyPr wrap="square" anchor="t" lIns="0" rIns="0" tIns="0" bIns="0">
-            <a:spAutoFit/>
-          </a:bodyPr>
-          <a:lstStyle/>
-          <a:p>
-            <a:pPr algn="l">
-              <a:lnSpc>
-                <a:spcPct val="105000"/>
-              </a:lnSpc>
-            </a:pPr>
-            <a:r>
-              <a:rPr sz="1000" b="0" i="0">
-                <a:solidFill>
-                  <a:srgbClr val="7F7F7F"/>
-                </a:solidFill>
-                <a:latin typeface="Calibri"/>
-              </a:rPr>
-              <a:t>대외비 · Confidential · 인사팀 대상 설명자료</a:t>
-            </a:r>
-          </a:p>
-        </p:txBody>
-      </p:sp>
-      <p:sp>
-        <p:nvSpPr>
-          <p:cNvPr id="8" name="TextBox 7"/>
-          <p:cNvSpPr txBox="1"/>
-          <p:nvPr/>
-        </p:nvSpPr>
-        <p:spPr>
-          <a:xfrm>
-            <a:off x="10454335" y="6291072"/>
-            <a:ext cx="1097280" cy="384048"/>
-          </a:xfrm>
-          <a:prstGeom prst="rect">
-            <a:avLst/>
-          </a:prstGeom>
-          <a:noFill/>
-        </p:spPr>
-        <p:txBody>
-          <a:bodyPr wrap="square" anchor="t" lIns="0" rIns="0" tIns="0" bIns="0">
-            <a:spAutoFit/>
-          </a:bodyPr>
-          <a:lstStyle/>
-          <a:p>
-            <a:pPr algn="r">
-              <a:lnSpc>
-                <a:spcPct val="105000"/>
-              </a:lnSpc>
-            </a:pPr>
-            <a:r>
-              <a:rPr sz="1600" b="0" i="0">
-                <a:solidFill>
-                  <a:srgbClr val="7F7F7F"/>
-                </a:solidFill>
-                <a:latin typeface="Calibri"/>
-              </a:rPr>
-              <a:t>6</a:t>
-            </a:r>
-          </a:p>
-        </p:txBody>
-      </p:sp>
-      <p:sp>
-        <p:nvSpPr>
-          <p:cNvPr id="9" name="TextBox 8"/>
-          <p:cNvSpPr txBox="1"/>
-          <p:nvPr/>
-        </p:nvSpPr>
-        <p:spPr>
-          <a:xfrm>
-            <a:off x="8808415" y="182880"/>
-            <a:ext cx="2743200" cy="548640"/>
-          </a:xfrm>
-          <a:prstGeom prst="rect">
-            <a:avLst/>
-          </a:prstGeom>
-          <a:noFill/>
-        </p:spPr>
-        <p:txBody>
-          <a:bodyPr wrap="square" anchor="t" lIns="0" rIns="0" tIns="0" bIns="0">
-            <a:spAutoFit/>
-          </a:bodyPr>
-          <a:lstStyle/>
-          <a:p>
-            <a:pPr algn="r">
-              <a:lnSpc>
-                <a:spcPct val="105000"/>
-              </a:lnSpc>
-            </a:pPr>
-            <a:r>
-              <a:rPr sz="1800" b="1" i="0">
-                <a:solidFill>
-                  <a:srgbClr val="FFFFFF"/>
-                </a:solidFill>
-                <a:latin typeface="Calibri"/>
-              </a:rPr>
-              <a:t>Confidential</a:t>
-            </a:r>
-          </a:p>
-        </p:txBody>
-      </p:sp>
-    </p:spTree>
-  </p:cSld>
-  <p:clrMapOvr>
-    <a:masterClrMapping/>
-  </p:clrMapOvr>
-</p:sld>
-</file>
-
-<file path=ppt/slides/slide7.xml><?xml version="1.0" encoding="utf-8"?>
-<p:sld xmlns:a="http://schemas.openxmlformats.org/drawingml/2006/main" xmlns:p="http://schemas.openxmlformats.org/presentationml/2006/main" xmlns:r="http://schemas.openxmlformats.org/officeDocument/2006/relationships">
-  <p:cSld>
-    <p:spTree>
-      <p:nvGrpSpPr>
-        <p:cNvPr id="1" name=""/>
-        <p:cNvGrpSpPr/>
-        <p:nvPr/>
-      </p:nvGrpSpPr>
-      <p:grpSpPr/>
-      <p:sp>
-        <p:nvSpPr>
-          <p:cNvPr id="2" name="Rectangle 1"/>
-          <p:cNvSpPr/>
-          <p:nvPr/>
-        </p:nvSpPr>
-        <p:spPr>
-          <a:xfrm>
-            <a:off x="0" y="0"/>
-            <a:ext cx="12191695" cy="6858000"/>
-          </a:xfrm>
-          <a:prstGeom prst="rect">
-            <a:avLst/>
-          </a:prstGeom>
-          <a:solidFill>
-            <a:srgbClr val="111111"/>
-          </a:solidFill>
-          <a:ln>
-            <a:noFill/>
-          </a:ln>
-          <a:effectLst/>
-        </p:spPr>
-        <p:style>
-          <a:lnRef idx="1">
-            <a:schemeClr val="accent1"/>
-          </a:lnRef>
-          <a:fillRef idx="3">
-            <a:schemeClr val="accent1"/>
-          </a:fillRef>
-          <a:effectRef idx="2">
-            <a:schemeClr val="accent1"/>
-          </a:effectRef>
-          <a:fontRef idx="minor">
-            <a:schemeClr val="lt1"/>
-          </a:fontRef>
-        </p:style>
-        <p:txBody>
-          <a:bodyPr rtlCol="0" anchor="ctr"/>
-          <a:lstStyle/>
-          <a:p>
-            <a:pPr algn="ctr"/>
-          </a:p>
-        </p:txBody>
-      </p:sp>
-      <p:sp>
-        <p:nvSpPr>
-          <p:cNvPr id="3" name="Rectangle 2"/>
-          <p:cNvSpPr/>
-          <p:nvPr/>
-        </p:nvSpPr>
-        <p:spPr>
-          <a:xfrm>
-            <a:off x="0" y="6492240"/>
-            <a:ext cx="12191695" cy="365760"/>
-          </a:xfrm>
-          <a:prstGeom prst="rect">
-            <a:avLst/>
-          </a:prstGeom>
-          <a:solidFill>
-            <a:srgbClr val="2F5597"/>
-          </a:solidFill>
-          <a:ln>
-            <a:noFill/>
-          </a:ln>
-          <a:effectLst/>
-        </p:spPr>
-        <p:style>
-          <a:lnRef idx="1">
-            <a:schemeClr val="accent1"/>
-          </a:lnRef>
-          <a:fillRef idx="3">
-            <a:schemeClr val="accent1"/>
-          </a:fillRef>
-          <a:effectRef idx="2">
-            <a:schemeClr val="accent1"/>
-          </a:effectRef>
-          <a:fontRef idx="minor">
-            <a:schemeClr val="lt1"/>
-          </a:fontRef>
-        </p:style>
-        <p:txBody>
-          <a:bodyPr rtlCol="0" anchor="ctr"/>
-          <a:lstStyle/>
-          <a:p>
-            <a:pPr algn="ctr"/>
-          </a:p>
-        </p:txBody>
-      </p:sp>
-      <p:sp>
-        <p:nvSpPr>
-          <p:cNvPr id="4" name="TextBox 3"/>
-          <p:cNvSpPr txBox="1"/>
-          <p:nvPr/>
-        </p:nvSpPr>
-        <p:spPr>
-          <a:xfrm>
-            <a:off x="640080" y="2377440"/>
-            <a:ext cx="10911535" cy="1463040"/>
-          </a:xfrm>
-          <a:prstGeom prst="rect">
-            <a:avLst/>
-          </a:prstGeom>
-          <a:noFill/>
-        </p:spPr>
-        <p:txBody>
-          <a:bodyPr wrap="square" anchor="t" lIns="0" rIns="0" tIns="0" bIns="0">
-            <a:spAutoFit/>
-          </a:bodyPr>
-          <a:lstStyle/>
-          <a:p>
-            <a:pPr algn="ctr">
-              <a:lnSpc>
-                <a:spcPct val="105000"/>
-              </a:lnSpc>
-            </a:pPr>
-            <a:r>
-              <a:rPr sz="5000" b="1" i="0">
-                <a:solidFill>
-                  <a:srgbClr val="FFFFFF"/>
-                </a:solidFill>
-                <a:latin typeface="Calibri"/>
-              </a:rPr>
-              <a:t>시작하기</a:t>
+              <a:t>도입 안내</a:t>
             </a:r>
           </a:p>
         </p:txBody>
@@ -6602,7 +5128,7 @@
                 </a:solidFill>
                 <a:latin typeface="Calibri"/>
               </a:rPr>
-              <a:t>담당자 키·도입 방법은 데이터보호 담당 부서로 문의해 주세요 · 데이터는 모두 합성(가상) 예시</a:t>
+              <a:t>도입·키 발급은 데이터보호 담당 부서로 문의 · 데이터는 합성 예시</a:t>
             </a:r>
           </a:p>
         </p:txBody>

</xml_diff>